<commit_message>
docs: normalize em-dashes to hyphens in the deck
Match the manual pass Yamit applied on main (4007262): the generator
now replaces em-dashes with hyphens at build time, leaving the
--unsafe-writes flag untouched.

Co-Authored-By: Claude Opus 4.8 <noreply@anthropic.com>
</commit_message>
<xml_diff>
--- a/MCP-auth-slides.pptx
+++ b/MCP-auth-slides.pptx
@@ -600,7 +600,7 @@
           <a:lstStyle/>
           <a:p>
             <a:r>
-              <a:t>This slide introduces the checks so later references resolve, and the Rule column is the point: every check is anchored to a MUST or SHOULD in the spec (only #8 CORS is non-MCP). Don't read all 14 — say the grouping: whether a stranger can reach the tools (1, 13), transport safety (2, 5), discovering the login (3, 4, 10), OAuth hygiene in the metadata (9, 11), session and browser defences (6, 7, 8), and the two write checks (12, 14). The next slides explain each group and cite its clause.</a:t>
+              <a:t>This slide introduces the checks so later references resolve, and the Rule column is the point: every check is anchored to a MUST or SHOULD in the spec (only #8 CORS is non-MCP). Don't read all 14 - say the grouping: whether a stranger can reach the tools (1, 13), transport safety (2, 5), discovering the login (3, 4, 10), OAuth hygiene in the metadata (9, 11), session and browser defences (6, 7, 8), and the two write checks (12, 14). The next slides explain each group and cite its clause.</a:t>
             </a:r>
           </a:p>
         </p:txBody>
@@ -740,7 +740,7 @@
           <a:lstStyle/>
           <a:p>
             <a:r>
-              <a:t>Pure transport hygiene now that #3 has moved to discovery. #2 actually connects and checks the certificate — 'the URL says https' is not 'TLS works'. #5 is tied to the session era (2025-03-26 to 2025-11-25) and is inconclusive on most servers because we don't implement the deprecated two-connection transport it needs — be ready to say that.</a:t>
+              <a:t>Pure transport hygiene now that #3 has moved to discovery. #2 actually connects and checks the certificate - 'the URL says https' is not 'TLS works'. #5 is tied to the session era (2025-03-26 to 2025-11-25) and is inconclusive on most servers because we don't implement the deprecated two-connection transport it needs - be ready to say that.</a:t>
             </a:r>
           </a:p>
         </p:txBody>
@@ -880,7 +880,7 @@
           <a:lstStyle/>
           <a:p>
             <a:r>
-              <a:t>#6: explain 'length isn't entropy' — keyspace = length times alphabet size. #7: the control request is the clever bit — a 403 alone proves nothing; only a server that accepts the control and rejects the forged Origin is really validating. Be upfront that Origin validation is largely ceremonial for a remote https server. #8: our weakest check, kept because it costs one request and is clearly labelled non-MCP.</a:t>
+              <a:t>#6: explain 'length isn't entropy' - keyspace = length times alphabet size. #7: the control request is the clever bit - a 403 alone proves nothing; only a server that accepts the control and rejects the forged Origin is really validating. Be upfront that Origin validation is largely ceremonial for a remote https server. #8: our weakest check, kept because it costs one request and is clearly labelled non-MCP.</a:t>
             </a:r>
           </a:p>
         </p:txBody>
@@ -950,7 +950,7 @@
           <a:lstStyle/>
           <a:p>
             <a:r>
-              <a:t>These two are pure reads of the discovered metadata — a good illustration of the 'fetch once, read many' design. #11's subtlety: OAuth response types are space-delimited sets, so 'id_token token' includes 'token' (the hybrid flow); a naive membership test missed it. If the login server's metadata was declared untrustworthy (#10), #9 and #11 do not read it either.</a:t>
+              <a:t>These two are pure reads of the discovered metadata - a good illustration of the 'fetch once, read many' design. #11's subtlety: OAuth response types are space-delimited sets, so 'id_token token' includes 'token' (the hybrid flow); a naive membership test missed it. If the login server's metadata was declared untrustworthy (#10), #9 and #11 do not read it either.</a:t>
             </a:r>
           </a:p>
         </p:txBody>
@@ -1020,7 +1020,7 @@
           <a:lstStyle/>
           <a:p>
             <a:r>
-              <a:t>These are the only two write checks. #12 registers a client; #14 must register one to have something whose redirect rules it can test. Both are off by default and journalled before cleanup. The cost of running them, and what #14 found, come in the results and ethics sections — don't pre-empt the numbers here.</a:t>
+              <a:t>These are the only two write checks. #12 registers a client; #14 must register one to have something whose redirect rules it can test. Both are off by default and journalled before cleanup. The cost of running them, and what #14 found, come in the results and ethics sections - don't pre-empt the numbers here.</a:t>
             </a:r>
           </a:p>
         </p:txBody>
@@ -1090,7 +1090,7 @@
           <a:lstStyle/>
           <a:p>
             <a:r>
-              <a:t>Emphasise: one consistent run — every number that follows comes from the same scan on the same day, directly comparable. No ERROR verdicts because we removed five endpoints that had gone dead since earlier runs. Name the two populations clearly: the 83 real public servers we MEASURE (from the MCP Registry) versus the 7 local practice servers we BUILT to test the tool (detailed at slide 23). Be first to say 83 is a thin slice of the registry, not internet-wide rates.</a:t>
+              <a:t>Emphasise: one consistent run - every number that follows comes from the same scan on the same day, directly comparable. No ERROR verdicts because we removed five endpoints that had gone dead since earlier runs. Name the two populations clearly: the 83 real public servers we MEASURE (from the MCP Registry) versus the 7 local practice servers we BUILT to test the tool (detailed at slide 23). Be first to say 83 is a thin slice of the registry, not internet-wide rates.</a:t>
             </a:r>
           </a:p>
         </p:txBody>
@@ -1160,7 +1160,7 @@
           <a:lstStyle/>
           <a:p>
             <a:r>
-              <a:t>Walk only the highlights (#1=28, open-dcr=38, #13=22). If asked about #4/#10 precision: hf.co answers a redirect we grade as 'absent' though its target is a valid document, so those two counts are each at least one high — worth conceding if an examiner clicks a link. The three following slides zoom into the findings that matter.</a:t>
+              <a:t>Walk only the highlights (#1=28, open-dcr=38, #13=22). If asked about #4/#10 precision: hf.co answers a redirect we grade as 'absent' though its target is a valid document, so those two counts are each at least one high - worth conceding if an examiner clicks a link. The three following slides zoom into the findings that matter.</a:t>
             </a:r>
           </a:p>
         </p:txBody>
@@ -1230,7 +1230,7 @@
           <a:lstStyle/>
           <a:p>
             <a:r>
-              <a:t>Be precise: this proves the catalogue is readable without login — capability disclosure. It does NOT by itself prove you can run the tools; the next slide settles that. The open ones cluster among lesser-known entries; recognisable vendors all gate. Disclosure is the reconnaissance step.</a:t>
+              <a:t>Be precise: this proves the catalogue is readable without login - capability disclosure. It does NOT by itself prove you can run the tools; the next slide settles that. The open ones cluster among lesser-known entries; recognisable vendors all gate. Disclosure is the reconnaissance step.</a:t>
             </a:r>
           </a:p>
         </p:txBody>
@@ -1300,7 +1300,7 @@
           <a:lstStyle/>
           <a:p>
             <a:r>
-              <a:t>The professor knows HTTP but not MCP. Frame it: an MCP server is a small web API exposing a menu of actions to an AI; the protocol standardises the menu and the messages but leaves security — requiring a login (authentication) and enforcing what a caller may do (authorization) — to the implementer. JSON-RPC = calling a named method with parameters and getting a result or error; MCP uses initialize, tools/list, tools/call.</a:t>
+              <a:t>The professor knows HTTP but not MCP. Frame it: an MCP server is a small web API exposing a menu of actions to an AI; the protocol standardises the menu and the messages but leaves security - requiring a login (authentication) and enforcing what a caller may do (authorization) - to the implementer. JSON-RPC = calling a named method with parameters and getting a result or error; MCP uses initialize, tools/list, tools/call.</a:t>
             </a:r>
           </a:p>
         </p:txBody>
@@ -1370,7 +1370,7 @@
           <a:lstStyle/>
           <a:p>
             <a:r>
-              <a:t>The result to be proud of. Six of the 28 disclose their catalogue but return 401 on tools/call. Show the dock evidence. If asked why a reply proves 'past the gate' for tools/call but a 200 does not for #14: different endpoints — tools/call is a JSON-RPC method (any reply = past the transport gate), while #14's /authorize is a browser page where a 200 is just a login form.</a:t>
+              <a:t>The result to be proud of. Six of the 28 disclose their catalogue but return 401 on tools/call. Show the dock evidence. If asked why a reply proves 'past the gate' for tools/call but a 200 does not for #14: different endpoints - tools/call is a JSON-RPC method (any reply = past the transport gate), while #14's /authorize is a browser page where a 200 is just a login form.</a:t>
             </a:r>
           </a:p>
         </p:txBody>
@@ -1440,7 +1440,7 @@
           <a:lstStyle/>
           <a:p>
             <a:r>
-              <a:t>Strengthen the importance. DCR normally means a developer registers an app once by hand; open DCR automates it for anyone. Walk the 3-step attack chain aloud: register a plausible client, lure a user into approving it, receive tokens issued for that user. It is the foothold the MCP spec's own security section warns about, and the only piece of the identity-confusion risk observable without a token — which is why it earns a finding even though it breaks no rule. The write cost of running this and #14 is the next slide.</a:t>
+              <a:t>Strengthen the importance. DCR normally means a developer registers an app once by hand; open DCR automates it for anyone. Walk the 3-step attack chain aloud: register a plausible client, lure a user into approving it, receive tokens issued for that user. It is the foothold the MCP spec's own security section warns about, and the only piece of the identity-confusion risk observable without a token - which is why it earns a finding even though it breaks no rule. The write cost of running this and #14 is the next slide.</a:t>
             </a:r>
           </a:p>
         </p:txBody>
@@ -1510,7 +1510,7 @@
           <a:lstStyle/>
           <a:p>
             <a:r>
-              <a:t>The insight, not the litter: only servers running a real OAuth flow were testable, and none of them mishandled the redirect address (23 confirmed reject, 24 behind a login wall). Security features travel together — the servers mature enough to support DCR + auth-code also validated redirect URIs, foreshadowing 'security tracks maturity' on the closing slide. Cost backup if asked: running the two write checks left 76 client registrations we couldn't delete (38 + 38); all inert, self-expiring, and journalled before any delete attempt. If asked why 200 isn't a finding for #14: the /authorize 200 is just a login form; the dangerous event is a redirect to the attacker's address, which we never saw.</a:t>
+              <a:t>The insight, not the litter: only servers running a real OAuth flow were testable, and none of them mishandled the redirect address (23 confirmed reject, 24 behind a login wall). Security features travel together - the servers mature enough to support DCR + auth-code also validated redirect URIs, foreshadowing 'security tracks maturity' on the closing slide. Cost backup if asked: running the two write checks left 76 client registrations we couldn't delete (38 + 38); all inert, self-expiring, and journalled before any delete attempt. If asked why 200 isn't a finding for #14: the /authorize 200 is just a login form; the dangerous event is a redirect to the attacker's address, which we never saw.</a:t>
             </a:r>
           </a:p>
         </p:txBody>
@@ -1650,7 +1650,7 @@
           <a:lstStyle/>
           <a:p>
             <a:r>
-              <a:t>Say the caveat sentence slowly — it is the single most important sentence in the talk. The two-hop picture explains WHY the deeper gaps are out of reach: the MCP server is a middleman in front of a true back-end, and the dangerous auth mistakes happen on that hop, invisible from outside even with a token. PKCE = a proof that the app finishing a login started it; we can't observe it without completing a login.</a:t>
+              <a:t>Say the caveat sentence slowly - it is the single most important sentence in the talk. The two-hop picture explains WHY the deeper gaps are out of reach: the MCP server is a middleman in front of a true back-end, and the dangerous auth mistakes happen on that hop, invisible from outside even with a token. PKCE = a proof that the app finishing a login started it; we can't observe it without completing a login.</a:t>
             </a:r>
           </a:p>
         </p:txBody>
@@ -1720,7 +1720,7 @@
           <a:lstStyle/>
           <a:p>
             <a:r>
-              <a:t>Key nuance the professor will want: servers self-report their revision in the initialize handshake, and the installed base lags — plenty still run 2025-03-26 or 2024-11-05, so checks tied to older rules (sessions: #5, #6) still describe real servers we scanned. A newer spec does not retroactively fix an older server. Present the changes as context, not as failure.</a:t>
+              <a:t>Key nuance the professor will want: servers self-report their revision in the initialize handshake, and the installed base lags - plenty still run 2025-03-26 or 2024-11-05, so checks tied to older rules (sessions: #5, #6) still describe real servers we scanned. A newer spec does not retroactively fix an older server. Present the changes as context, not as failure.</a:t>
             </a:r>
           </a:p>
         </p:txBody>
@@ -1790,7 +1790,7 @@
           <a:lstStyle/>
           <a:p>
             <a:r>
-              <a:t>Direction A. Lead with the thesis sentence, slowly. Then the WHY, straight from our proposal: the MCP spec marks authorization OPTIONAL, Anthropic's own quick-start and most YouTube/Google guides stand up a fastMCP server in 2–5 minutes with auth off, and only mention it later as an optional feature — so servers shipping without auth is the predictable default, not a surprise. Then WHAT we found (the maturity gradient) and WHAT we built (a reproducible, evidence-backed instrument). Close on the kicker line, then invite questions.</a:t>
+              <a:t>Direction A. Lead with the thesis sentence, slowly. Then the WHY, straight from our proposal: the MCP spec marks authorization OPTIONAL, Anthropic's own quick-start and most YouTube/Google guides stand up a fastMCP server in 2–5 minutes with auth off, and only mention it later as an optional feature - so servers shipping without auth is the predictable default, not a surprise. Then WHAT we found (the maturity gradient) and WHAT we built (a reproducible, evidence-backed instrument). Close on the kicker line, then invite questions.</a:t>
             </a:r>
           </a:p>
         </p:txBody>
@@ -1860,7 +1860,7 @@
           <a:lstStyle/>
           <a:p>
             <a:r>
-              <a:t>Backup slide — jump here if the question arises; otherwise skip.</a:t>
+              <a:t>Backup slide - jump here if the question arises; otherwise skip.</a:t>
             </a:r>
           </a:p>
         </p:txBody>
@@ -1930,7 +1930,7 @@
           <a:lstStyle/>
           <a:p>
             <a:r>
-              <a:t>Backup slide — jump here if the question arises; otherwise skip.</a:t>
+              <a:t>Backup slide - jump here if the question arises; otherwise skip.</a:t>
             </a:r>
           </a:p>
         </p:txBody>
@@ -2000,7 +2000,7 @@
           <a:lstStyle/>
           <a:p>
             <a:r>
-              <a:t>Backup slide — jump here if the question arises; otherwise skip.</a:t>
+              <a:t>Backup slide - jump here if the question arises; otherwise skip.</a:t>
             </a:r>
           </a:p>
         </p:txBody>
@@ -2070,7 +2070,7 @@
           <a:lstStyle/>
           <a:p>
             <a:r>
-              <a:t>MCP adopted OAuth 2.1 and wrote rules for how servers must use it. Stress the split: MCP server and login server are often different companies — that's why finding the login later takes two pages. A token is bearer. Why OAuth not passwords: the app never sees your password; the auth server does the login and returns a scoped, revocable token.</a:t>
+              <a:t>MCP adopted OAuth 2.1 and wrote rules for how servers must use it. Stress the split: MCP server and login server are often different companies - that's why finding the login later takes two pages. A token is bearer. Why OAuth not passwords: the app never sees your password; the auth server does the login and returns a scoped, revocable token.</a:t>
             </a:r>
           </a:p>
         </p:txBody>
@@ -2140,7 +2140,7 @@
           <a:lstStyle/>
           <a:p>
             <a:r>
-              <a:t>Three angles were considered; this one is meaningful AND runnable without accounts on 83 services. The question spans the whole authorization surface an outsider can see — transport, discovery (is login advertised), enforcement, and OAuth configuration — the 14 checks introduced next. Stress that 'what a server advertises and enforces at its front door, not whether it is sound behind it' is the single most important caveat, and that you return to it at the end (slide 24). The other two angles — token passthrough and identity confusion — need a real logged-in session and evidence on a back-end we can't see.</a:t>
+              <a:t>Three angles were considered; this one is meaningful AND runnable without accounts on 83 services. The question spans the whole authorization surface an outsider can see - transport, discovery (is login advertised), enforcement, and OAuth configuration - the 14 checks introduced next. Stress that 'what a server advertises and enforces at its front door, not whether it is sound behind it' is the single most important caveat, and that you return to it at the end (slide 24). The other two angles - token passthrough and identity confusion - need a real logged-in session and evidence on a back-end we can't see.</a:t>
             </a:r>
           </a:p>
         </p:txBody>
@@ -2210,7 +2210,7 @@
           <a:lstStyle/>
           <a:p>
             <a:r>
-              <a:t>This is the honest core. We never send anyone to log in, never obtain a token, never reach step 3. Against a wide-open server, step 1 just succeeds — which is exactly what the first check reports. Because we hold nothing, every result is about advertisement and enforcement, not soundness.</a:t>
+              <a:t>This is the honest core. We never send anyone to log in, never obtain a token, never reach step 3. Against a wide-open server, step 1 just succeeds - which is exactly what the first check reports. Because we hold nothing, every result is about advertisement and enforcement, not soundness.</a:t>
             </a:r>
           </a:p>
         </p:txBody>
@@ -2350,7 +2350,7 @@
           <a:lstStyle/>
           <a:p>
             <a:r>
-              <a:t>Emphasise that INCONCLUSIVE is honest, not a failure. The #14 example is the clearest: we register a client, then start a login with a redirect URI that was never registered. A strict server rejects it; a broken one would redirect to it. But a server that answers 200 with a login page is genuinely undecidable from outside — resolving it would require completing the login, which we never do. So INCONCLUSIVE is the correct verdict, not a guess or a cop-out. #14 is introduced in full later (slide 22); here it just illustrates the verdict.</a:t>
+              <a:t>Emphasise that INCONCLUSIVE is honest, not a failure. The #14 example is the clearest: we register a client, then start a login with a redirect URI that was never registered. A strict server rejects it; a broken one would redirect to it. But a server that answers 200 with a login page is genuinely undecidable from outside - resolving it would require completing the login, which we never do. So INCONCLUSIVE is the correct verdict, not a guess or a cop-out. #14 is introduced in full later (slide 22); here it just illustrates the verdict.</a:t>
             </a:r>
           </a:p>
         </p:txBody>
@@ -2490,7 +2490,7 @@
           <a:lstStyle/>
           <a:p>
             <a:r>
-              <a:t>Present this as the strongest safety point: it was a fix, not a precaution. Tell the api.llow.io story — the scanner obeyed a target's metadata and wrote to a different company — then that containment now exists and has fired for real (semgrep). Framing: an SSRF-style risk that our own tool could be turned against third parties it was never meant to touch; we hit it for real and then contained it. (Avoid the term 'confused deputy' on the slide — it collides with the abandoned Tier-3 gap of the same name.)</a:t>
+              <a:t>Present this as the strongest safety point: it was a fix, not a precaution. Tell the api.llow.io story - the scanner obeyed a target's metadata and wrote to a different company - then that containment now exists and has fired for real (semgrep). Framing: an SSRF-style risk that our own tool could be turned against third parties it was never meant to touch; we hit it for real and then contained it. (Avoid the term 'confused deputy' on the slide - it collides with the abandoned Tier-3 gap of the same name.)</a:t>
             </a:r>
           </a:p>
         </p:txBody>
@@ -5608,7 +5608,7 @@
                 </a:solidFill>
                 <a:latin typeface="Calibri"/>
               </a:rPr>
-              <a:t>A scanner that measures a server's login setup from the outside — without ever logging in.</a:t>
+              <a:t>A scanner that measures a server's login setup from the outside - without ever logging in.</a:t>
             </a:r>
           </a:p>
         </p:txBody>
@@ -5707,7 +5707,7 @@
                 </a:solidFill>
                 <a:latin typeface="Calibri"/>
               </a:rPr>
-              <a:t>public MCP servers hand their tool list to a stranger — no login.</a:t>
+              <a:t>public MCP servers hand their tool list to a stranger - no login.</a:t>
             </a:r>
           </a:p>
         </p:txBody>
@@ -7852,7 +7852,7 @@
                 </a:solidFill>
                 <a:latin typeface="Calibri"/>
               </a:rPr>
-              <a:t>no-authentication-remote  —  can a stranger LIST the tools?</a:t>
+              <a:t>no-authentication-remote  -  can a stranger LIST the tools?</a:t>
             </a:r>
             <a:r>
               <a:rPr sz="1200" b="1" i="0">
@@ -7976,7 +7976,7 @@
                 </a:solidFill>
                 <a:latin typeface="Calibri"/>
               </a:rPr>
-              <a:t>unauthenticated-tool-invocation  —  can a stranger RUN one?</a:t>
+              <a:t>unauthenticated-tool-invocation  -  can a stranger RUN one?</a:t>
             </a:r>
             <a:r>
               <a:rPr sz="1200" b="1" i="0">
@@ -8001,7 +8001,7 @@
                 </a:solidFill>
                 <a:latin typeface="Calibri"/>
               </a:rPr>
-              <a:t>Send tools/call for a deliberately non-existent tool, no token — so nothing executes. A 401 means the call path is gated; any JSON-RPC reply means it reached the dispatch layer, i.e. invocation is open.</a:t>
+              <a:t>Send tools/call for a deliberately non-existent tool, no token - so nothing executes. A 401 means the call path is gated; any JSON-RPC reply means it reached the dispatch layer, i.e. invocation is open.</a:t>
             </a:r>
           </a:p>
         </p:txBody>
@@ -8097,7 +8097,7 @@
                 </a:solidFill>
                 <a:latin typeface="Calibri"/>
               </a:rPr>
-              <a:t>reading a menu is not ordering from it. #1 shows the menu is readable by anyone; #13 shows whether a stranger can actually place an order. Plenty of servers hand out the menu but still require a login before they serve — only #13 separates the two.</a:t>
+              <a:t>reading a menu is not ordering from it. #1 shows the menu is readable by anyone; #13 shows whether a stranger can actually place an order. Plenty of servers hand out the menu but still require a login before they serve - only #13 separates the two.</a:t>
             </a:r>
           </a:p>
         </p:txBody>
@@ -8317,7 +8317,7 @@
                 </a:solidFill>
                 <a:latin typeface="Calibri"/>
               </a:rPr>
-              <a:t>Plain http on a public host — or https whose certificate is expired, self-signed, or for the wrong name. Either way the traffic isn't really protected and a token would travel exposed.</a:t>
+              <a:t>Plain http on a public host - or https whose certificate is expired, self-signed, or for the wrong name. Either way the traffic isn't really protected and a token would travel exposed.</a:t>
             </a:r>
           </a:p>
         </p:txBody>
@@ -8441,7 +8441,7 @@
                 </a:solidFill>
                 <a:latin typeface="Calibri"/>
               </a:rPr>
-              <a:t>Is the session tag placed in the web address instead of a header? URLs end up in server logs, browser history and the Referer header — so the tag leaks.</a:t>
+              <a:t>Is the session tag placed in the web address instead of a header? URLs end up in server logs, browser history and the Referer header - so the tag leaks.</a:t>
             </a:r>
           </a:p>
         </p:txBody>
@@ -8726,7 +8726,7 @@
                 </a:solidFill>
                 <a:latin typeface="Calibri"/>
               </a:rPr>
-              <a:t> (#10) — often across different companies.</a:t>
+              <a:t> (#10) - often across different companies.</a:t>
             </a:r>
           </a:p>
         </p:txBody>
@@ -8850,7 +8850,7 @@
                 </a:solidFill>
                 <a:latin typeface="Calibri"/>
               </a:rPr>
-              <a:t>When a server correctly refuses with 401 “log in first”, it must also say WHERE — a WWW-Authenticate header pointing at its login-info page. Many just say “no” and leave the client stuck with nowhere to go.</a:t>
+              <a:t>When a server correctly refuses with 401 “log in first”, it must also say WHERE - a WWW-Authenticate header pointing at its login-info page. Many just say “no” and leave the client stuck with nowhere to go.</a:t>
             </a:r>
           </a:p>
         </p:txBody>
@@ -8974,7 +8974,7 @@
                 </a:solidFill>
                 <a:latin typeface="Calibri"/>
               </a:rPr>
-              <a:t>Does the MCP server publish the page naming its login server? Without it a client can't find where to authenticate. We query the exact spec address (a well-known path inserted before the server's path), not the bare domain — or we'd falsely accuse servers hosted under a path.</a:t>
+              <a:t>Does the MCP server publish the page naming its login server? Without it a client can't find where to authenticate. We query the exact spec address (a well-known path inserted before the server's path), not the bare domain - or we'd falsely accuse servers hosted under a path.</a:t>
             </a:r>
           </a:p>
         </p:txBody>
@@ -9133,7 +9133,7 @@
                 </a:solidFill>
                 <a:latin typeface="Calibri"/>
               </a:rPr>
-              <a:t>These share one lookup, fetched once at the start — so #4, #9, #10, #11 and #14 all reason about the same copy.</a:t>
+              <a:t>These share one lookup, fetched once at the start - so #4, #9, #10, #11 and #14 all reason about the same copy.</a:t>
             </a:r>
           </a:p>
         </p:txBody>
@@ -9353,7 +9353,7 @@
                 </a:solidFill>
                 <a:latin typeface="Calibri"/>
               </a:rPr>
-              <a:t>Open several sessions and compare the tags. Counting up, identical, or too little randomness = guessable. Key idea: length is not entropy — a 15-char random token beats a 16-digit counter.</a:t>
+              <a:t>Open several sessions and compare the tags. Counting up, identical, or too little randomness = guessable. Key idea: length is not entropy - a 15-char random token beats a 16-digit counter.</a:t>
             </a:r>
           </a:p>
         </p:txBody>
@@ -9477,7 +9477,7 @@
                 </a:solidFill>
                 <a:latin typeface="Calibri"/>
               </a:rPr>
-              <a:t>Send a request with a forged Origin. A refusal only counts if a no-Origin control is accepted — otherwise the server just refuses everything. Guards against DNS-rebinding, mainly a threat to local servers.</a:t>
+              <a:t>Send a request with a forged Origin. A refusal only counts if a no-Origin control is accepted - otherwise the server just refuses everything. Guards against DNS-rebinding, mainly a threat to local servers.</a:t>
             </a:r>
           </a:p>
         </p:txBody>
@@ -9601,7 +9601,7 @@
                 </a:solidFill>
                 <a:latin typeface="Calibri"/>
               </a:rPr>
-              <a:t>Does it tell browsers “any website may call me” and “you may send credentials”? Not an MCP rule — reported as general web security, and only relevant if a browser is involved.</a:t>
+              <a:t>Does it tell browsers “any website may call me” and “you may send credentials”? Not an MCP rule - reported as general web security, and only relevant if a browser is involved.</a:t>
             </a:r>
           </a:p>
         </p:txBody>
@@ -9821,7 +9821,7 @@
                 </a:solidFill>
                 <a:latin typeface="Calibri"/>
               </a:rPr>
-              <a:t>Among the login addresses the server publishes, is any on plain http on a public host? Tokens would travel in the clear. Reads the shared lookup — it makes no request of its own.</a:t>
+              <a:t>Among the login addresses the server publishes, is any on plain http on a public host? Tokens would travel in the clear. Reads the shared lookup - it makes no request of its own.</a:t>
             </a:r>
           </a:p>
         </p:txBody>
@@ -10041,7 +10041,7 @@
                 </a:solidFill>
                 <a:latin typeface="Calibri"/>
               </a:rPr>
-              <a:t>These two catch that in what the server advertises about its own login — before a client ever sends a token. Subtlety in #11: the login server lists its supported modes as one space-separated value, so we parse that list rather than string-match it — that way a combined “id_token token” is still flagged as offering the leaky implicit flow, which a naive check would miss.</a:t>
+              <a:t>These two catch that in what the server advertises about its own login - before a client ever sends a token. Subtlety in #11: the login server lists its supported modes as one space-separated value, so we parse that list rather than string-match it - that way a combined “id_token token” is still flagged as offering the leaky implicit flow, which a naive check would miss.</a:t>
             </a:r>
           </a:p>
         </p:txBody>
@@ -10137,7 +10137,7 @@
                 </a:solidFill>
                 <a:latin typeface="Calibri"/>
               </a:rPr>
-              <a:t>The two checks that write — off by default (#12, #14)</a:t>
+              <a:t>The two checks that write - off by default (#12, #14)</a:t>
             </a:r>
           </a:p>
         </p:txBody>
@@ -10261,7 +10261,7 @@
                 </a:solidFill>
                 <a:latin typeface="Calibri"/>
               </a:rPr>
-              <a:t>Dynamic Client Registration (DCR) lets an app sign itself up with the login server, no human involved. #12 sends a real registration to ask: will the server hand out client credentials to anyone, with no review or vetting? Permitted by the rules, so reported as posture — but it is the foothold a bigger attack needs.</a:t>
+              <a:t>Dynamic Client Registration (DCR) lets an app sign itself up with the login server, no human involved. #12 sends a real registration to ask: will the server hand out client credentials to anyone, with no review or vetting? Permitted by the rules, so reported as posture - but it is the foothold a bigger attack needs.</a:t>
             </a:r>
           </a:p>
         </p:txBody>
@@ -10385,7 +10385,7 @@
                 </a:solidFill>
                 <a:latin typeface="Calibri"/>
               </a:rPr>
-              <a:t>After login, the server returns the user to a registered address carrying the login code. Does it accept an address the client never registered? If so, an attacker can steal the code. Needs a registered client first — so it also writes.</a:t>
+              <a:t>After login, the server returns the user to a registered address carrying the login code. Does it accept an address the client never registered? If so, an attacker can steal the code. Needs a registered client first - so it also writes.</a:t>
             </a:r>
           </a:p>
         </p:txBody>
@@ -10607,7 +10607,7 @@
                 </a:solidFill>
                 <a:latin typeface="Calibri"/>
               </a:rPr>
-              <a:t>One consistent scan per server on 2026-09-27 — one pass, all 14 checks, zero ERROR verdicts. Servers came from the official MCP Registry; the raw request/response for every server is committed.</a:t>
+              <a:t>One consistent scan per server on 2026-09-27 - one pass, all 14 checks, zero ERROR verdicts. Servers came from the official MCP Registry; the raw request/response for every server is committed.</a:t>
             </a:r>
           </a:p>
         </p:txBody>
@@ -11000,7 +11000,7 @@
                 </a:solidFill>
                 <a:latin typeface="Calibri"/>
               </a:rPr>
-              <a:t>These 83 are real, public servers from the official MCP Registry — a public directory of live MCP servers. Separately, we built 7 local practice servers to develop and validate the scanner itself (slide 23).</a:t>
+              <a:t>These 83 are real, public servers from the official MCP Registry - a public directory of live MCP servers. Separately, we built 7 local practice servers to develop and validate the scanner itself (slide 23).</a:t>
             </a:r>
           </a:p>
         </p:txBody>
@@ -13534,7 +13534,7 @@
                 </a:solidFill>
                 <a:latin typeface="Calibri"/>
               </a:rPr>
-              <a:t> — authenticating is only a SHOULD. What's notable is that nothing stops a stranger asking what a server can do.</a:t>
+              <a:t> - authenticating is only a SHOULD. What's notable is that nothing stops a stranger asking what a server can do.</a:t>
             </a:r>
           </a:p>
         </p:txBody>
@@ -13678,7 +13678,7 @@
                 </a:solidFill>
                 <a:latin typeface="Calibri"/>
               </a:rPr>
-              <a:t>MCP servers give an AI tools — and ship with no security</a:t>
+              <a:t>MCP servers give an AI tools - and ship with no security</a:t>
             </a:r>
           </a:p>
         </p:txBody>
@@ -13806,7 +13806,7 @@
                 </a:solidFill>
                 <a:latin typeface="Calibri"/>
               </a:rPr>
-              <a:t>•  Nothing forces a server to require a login, or to check what a caller may do — both are left to the implementer to enforce.</a:t>
+              <a:t>•  Nothing forces a server to require a login, or to check what a caller may do - both are left to the implementer to enforce.</a:t>
             </a:r>
           </a:p>
         </p:txBody>
@@ -14314,7 +14314,7 @@
                 </a:solidFill>
                 <a:latin typeface="Calibri"/>
               </a:rPr>
-              <a:t>Check #13 tested the invocation path directly on those 28 servers — and it changed the picture.</a:t>
+              <a:t>Check #13 tested the invocation path directly on those 28 servers - and it changed the picture.</a:t>
             </a:r>
           </a:p>
         </p:txBody>
@@ -14692,7 +14692,7 @@
                 </a:solidFill>
                 <a:latin typeface="Calibri"/>
               </a:rPr>
-              <a:t>The measured figure is 22, not 28. Claiming “anyone can use” on all 28 would have over-stated by about a fifth — #13 replaces that inference with a direct measurement.</a:t>
+              <a:t>The measured figure is 22, not 28. Claiming “anyone can use” on all 28 would have over-stated by about a fifth - #13 replaces that inference with a direct measurement.</a:t>
             </a:r>
           </a:p>
         </p:txBody>
@@ -14782,7 +14782,7 @@
                 </a:solidFill>
                 <a:latin typeface="Courier New"/>
               </a:rPr>
-              <a:t>dock  —  evidence</a:t>
+              <a:t>dock  -  evidence</a:t>
             </a:r>
           </a:p>
           <a:p>
@@ -15075,7 +15075,7 @@
                 </a:solidFill>
                 <a:latin typeface="Calibri"/>
               </a:rPr>
-              <a:t>register a client — no approval</a:t>
+              <a:t>register a client - no approval</a:t>
             </a:r>
           </a:p>
         </p:txBody>
@@ -15229,7 +15229,7 @@
                 </a:solidFill>
                 <a:latin typeface="Calibri"/>
               </a:rPr>
-              <a:t>a legitimate-looking client — no vetting.</a:t>
+              <a:t>a legitimate-looking client - no vetting.</a:t>
             </a:r>
           </a:p>
         </p:txBody>
@@ -15625,7 +15625,7 @@
                 </a:solidFill>
                 <a:latin typeface="Calibri"/>
               </a:rPr>
-              <a:t>Open registration breaks no rule — the spec permits it. But the spec itself flags it as the prerequisite for consent-phishing and client-impersonation attacks, and it is the one piece of the identity-confusion risk visible without any token. That is why we report it as posture, not a pass. (Of the rest: 35 advertise no registration at all; 10 were inconclusive.)</a:t>
+              <a:t>Open registration breaks no rule - the spec permits it. But the spec itself flags it as the prerequisite for consent-phishing and client-impersonation attacks, and it is the one piece of the identity-confusion risk visible without any token. That is why we report it as posture, not a pass. (Of the rest: 35 advertise no registration at all; 10 were inconclusive.)</a:t>
             </a:r>
           </a:p>
         </p:txBody>
@@ -15721,7 +15721,7 @@
                 </a:solidFill>
                 <a:latin typeface="Calibri"/>
               </a:rPr>
-              <a:t>Finding 4: the write check that found nothing — and what that tells us</a:t>
+              <a:t>Finding 4: the write check that found nothing - and what that tells us</a:t>
             </a:r>
           </a:p>
         </p:txBody>
@@ -15914,7 +15914,7 @@
                 </a:solidFill>
                 <a:latin typeface="Calibri"/>
               </a:rPr>
-              <a:t>Half were inconclusive because a real login server shows its login page before it validates the address — the same wall that puts deeper checks out of reach.</a:t>
+              <a:t>Half were inconclusive because a real login server shows its login page before it validates the address - the same wall that puts deeper checks out of reach.</a:t>
             </a:r>
           </a:p>
         </p:txBody>
@@ -16023,7 +16023,7 @@
                 </a:solidFill>
                 <a:latin typeface="Calibri"/>
               </a:rPr>
-              <a:t>Of the 47 we could test, none mishandled the forged return address: 23 rejected it outright, and 24 sat behind a login we can't pass. To even be testable, a server had to run a working OAuth registration-and-authorize flow — and the servers built well enough for that tended to validate the return address correctly too.</a:t>
+              <a:t>Of the 47 we could test, none mishandled the forged return address: 23 rejected it outright, and 24 sat behind a login we can't pass. To even be testable, a server had to run a working OAuth registration-and-authorize flow - and the servers built well enough for that tended to validate the return address correctly too.</a:t>
             </a:r>
           </a:p>
           <a:p>
@@ -16487,7 +16487,7 @@
                 </a:solidFill>
                 <a:latin typeface="Calibri"/>
               </a:rPr>
-              <a:t>38  live — boot a server and scan it</a:t>
+              <a:t>38  live - boot a server and scan it</a:t>
             </a:r>
           </a:p>
           <a:p>
@@ -16506,7 +16506,7 @@
                 </a:solidFill>
                 <a:latin typeface="Calibri"/>
               </a:rPr>
-              <a:t>111  unit — individual judgements</a:t>
+              <a:t>111  unit - individual judgements</a:t>
             </a:r>
           </a:p>
           <a:p>
@@ -16522,7 +16522,7 @@
                 </a:solidFill>
                 <a:latin typeface="Calibri"/>
               </a:rPr>
-              <a:t>64  regression — pin bugs we fixed</a:t>
+              <a:t>64  regression - pin bugs we fixed</a:t>
             </a:r>
           </a:p>
         </p:txBody>
@@ -17029,7 +17029,7 @@
                 </a:solidFill>
                 <a:latin typeface="Calibri"/>
               </a:rPr>
-              <a:t>we can see this hop                       invisible from outside — even with a token</a:t>
+              <a:t>we can see this hop                       invisible from outside - even with a token</a:t>
             </a:r>
           </a:p>
         </p:txBody>
@@ -17068,7 +17068,7 @@
                 </a:solidFill>
                 <a:latin typeface="Calibri"/>
               </a:rPr>
-              <a:t>We deliberately scoped the project to what a no-credential caller can observe. Some dangerous mistakes live on that second hop — a server passing your token to a back-end that shouldn't get it, or mixing up two users — which is not observable from outside in any case.</a:t>
+              <a:t>We deliberately scoped the project to what a no-credential caller can observe. Some dangerous mistakes live on that second hop - a server passing your token to a back-end that shouldn't get it, or mixing up two users - which is not observable from outside in any case.</a:t>
             </a:r>
           </a:p>
         </p:txBody>
@@ -17304,7 +17304,7 @@
                 </a:solidFill>
                 <a:latin typeface="Calibri"/>
               </a:rPr>
-              <a:t>Servers declare which revision they follow in the handshake — and many still run older ones. So the earlier rules (sessions included) still describe real servers in our sample; a newer spec does not retroactively fix them.</a:t>
+              <a:t>Servers declare which revision they follow in the handshake - and many still run older ones. So the earlier rules (sessions included) still describe real servers in our sample; a newer spec does not retroactively fix them.</a:t>
             </a:r>
           </a:p>
         </p:txBody>
@@ -17346,7 +17346,7 @@
                 </a:solidFill>
                 <a:latin typeface="Calibri"/>
               </a:rPr>
-              <a:t>•  Sessions were removed entirely in 2026-07-28 — so #5 and #6 still apply to the older revisions many servers keep running.</a:t>
+              <a:t>•  Sessions were removed entirely in 2026-07-28 - so #5 and #6 still apply to the older revisions many servers keep running.</a:t>
             </a:r>
           </a:p>
           <a:p>
@@ -17384,7 +17384,7 @@
                 </a:solidFill>
                 <a:latin typeface="Calibri"/>
               </a:rPr>
-              <a:t>•  Publishing the login-info page is now unconditional — which makes check #4 stronger.</a:t>
+              <a:t>•  Publishing the login-info page is now unconditional - which makes check #4 stronger.</a:t>
             </a:r>
           </a:p>
           <a:p>
@@ -17403,7 +17403,7 @@
                 </a:solidFill>
                 <a:latin typeface="Calibri"/>
               </a:rPr>
-              <a:t>•  Self-service registration is now deprecated — so #12's framing is already dated.</a:t>
+              <a:t>•  Self-service registration is now deprecated - so #12's framing is already dated.</a:t>
             </a:r>
           </a:p>
         </p:txBody>
@@ -17503,7 +17503,7 @@
                 </a:solidFill>
                 <a:latin typeface="Calibri"/>
               </a:rPr>
-              <a:t>MCP makes security optional — so the real question isn't whether it's secure, but which servers chose to be.</a:t>
+              <a:t>MCP makes security optional - so the real question isn't whether it's secure, but which servers chose to be.</a:t>
             </a:r>
           </a:p>
         </p:txBody>
@@ -17560,7 +17560,7 @@
                 </a:solidFill>
                 <a:latin typeface="Calibri"/>
               </a:rPr>
-              <a:t>, and most quick-starts spin up a server in two minutes with auth left off. Vulnerability in the wild isn't an accident — it's the default.</a:t>
+              <a:t>, and most quick-starts spin up a server in two minutes with auth left off. Vulnerability in the wild isn't an accident - it's the default.</a:t>
             </a:r>
           </a:p>
         </p:txBody>
@@ -17666,7 +17666,7 @@
                 </a:solidFill>
                 <a:latin typeface="Calibri"/>
               </a:rPr>
-              <a:t>Every recognisable vendor gated its tools; the servers open to a stranger were the newer, lesser-known ones — exactly what optional security predicts.</a:t>
+              <a:t>Every recognisable vendor gated its tools; the servers open to a stranger were the newer, lesser-known ones - exactly what optional security predicts.</a:t>
             </a:r>
           </a:p>
         </p:txBody>
@@ -17772,7 +17772,7 @@
                 </a:solidFill>
                 <a:latin typeface="Calibri"/>
               </a:rPr>
-              <a:t>An instrument that turns anecdote into measurement: 14 rule-based checks, each carrying its request and reply, reproducible against any public server — no login required.</a:t>
+              <a:t>An instrument that turns anecdote into measurement: 14 rule-based checks, each carrying its request and reply, reproducible against any public server - no login required.</a:t>
             </a:r>
           </a:p>
         </p:txBody>
@@ -17974,7 +17974,7 @@
                 </a:solidFill>
                 <a:latin typeface="Calibri"/>
               </a:rPr>
-              <a:t>No — every check cites a specific clause of a standard and returns the evidence for its verdict. The unit of output is a compliance judgement, not an open port.</a:t>
+              <a:t>No - every check cites a specific clause of a standard and returns the evidence for its verdict. The unit of output is a compliance judgement, not an open port.</a:t>
             </a:r>
           </a:p>
         </p:txBody>
@@ -18186,7 +18186,7 @@
                 </a:solidFill>
                 <a:latin typeface="Calibri"/>
               </a:rPr>
-              <a:t>They are other people's production servers. The point is measuring observable behaviour from outside — the position a real attacker is in.</a:t>
+              <a:t>They are other people's production servers. The point is measuring observable behaviour from outside - the position a real attacker is in.</a:t>
             </a:r>
           </a:p>
         </p:txBody>
@@ -18600,7 +18600,7 @@
                 </a:solidFill>
                 <a:latin typeface="Calibri"/>
               </a:rPr>
-              <a:t>Seven practice servers (one per posture) plus 213 tests — a check must pass against both a broken and a correct server.</a:t>
+              <a:t>Seven practice servers (one per posture) plus 213 tests - a check must pass against both a broken and a correct server.</a:t>
             </a:r>
           </a:p>
         </p:txBody>
@@ -18908,7 +18908,7 @@
                 </a:solidFill>
                 <a:latin typeface="Calibri"/>
               </a:rPr>
-              <a:t>Because the honest result and its cost — 76 registrations for zero findings — is the clearest measure of what write-class probing costs versus yields.</a:t>
+              <a:t>Because the honest result and its cost - 76 registrations for zero findings - is the clearest measure of what write-class probing costs versus yields.</a:t>
             </a:r>
           </a:p>
         </p:txBody>
@@ -19014,7 +19014,7 @@
                 </a:solidFill>
                 <a:latin typeface="Calibri"/>
               </a:rPr>
-              <a:t>This is our final submission, so nothing is planned — but the natural extensions are the 2026-07-28 revision (new headers), automatic registry discovery to scale past 83, and rate-limit handling.</a:t>
+              <a:t>This is our final submission, so nothing is planned - but the natural extensions are the 2026-07-28 revision (new headers), automatic registry discovery to scale past 83, and rate-limit handling.</a:t>
             </a:r>
           </a:p>
         </p:txBody>
@@ -19302,7 +19302,7 @@
                 </a:solidFill>
                 <a:latin typeface="Calibri"/>
               </a:rPr>
-              <a:t>a digital ticket — whoever holds it gets in, so a stolen one is as good as the original.</a:t>
+              <a:t>a digital ticket - whoever holds it gets in, so a stolen one is as good as the original.</a:t>
             </a:r>
           </a:p>
         </p:txBody>
@@ -19932,7 +19932,7 @@
                 </a:solidFill>
                 <a:latin typeface="Calibri"/>
               </a:rPr>
-              <a:t>Do real MCP servers implement MCP's authorization rules correctly — and can an outside caller with no account verify it, with evidence?</a:t>
+              <a:t>Do real MCP servers implement MCP's authorization rules correctly - and can an outside caller with no account verify it, with evidence?</a:t>
             </a:r>
           </a:p>
         </p:txBody>
@@ -19974,7 +19974,7 @@
                 </a:solidFill>
                 <a:latin typeface="Calibri"/>
               </a:rPr>
-              <a:t>Concretely — </a:t>
+              <a:t>Concretely - </a:t>
             </a:r>
             <a:r>
               <a:rPr sz="1600" b="0" i="0">
@@ -19999,7 +19999,7 @@
                 </a:solidFill>
                 <a:latin typeface="Calibri"/>
               </a:rPr>
-              <a:t>From the outside — </a:t>
+              <a:t>From the outside - </a:t>
             </a:r>
             <a:r>
               <a:rPr sz="1600" b="0" i="0">
@@ -20065,7 +20065,7 @@
                 </a:solidFill>
                 <a:latin typeface="Calibri"/>
               </a:rPr>
-              <a:t> — not whether the login is sound once you are through it.</a:t>
+              <a:t> - not whether the login is sound once you are through it.</a:t>
             </a:r>
           </a:p>
         </p:txBody>
@@ -20161,7 +20161,7 @@
                 </a:solidFill>
                 <a:latin typeface="Calibri"/>
               </a:rPr>
-              <a:t>How login works — and where the scanner stops</a:t>
+              <a:t>How login works - and where the scanner stops</a:t>
             </a:r>
           </a:p>
         </p:txBody>
@@ -20691,7 +20691,7 @@
                 </a:solidFill>
                 <a:latin typeface="Calibri"/>
               </a:rPr>
-              <a:t>The login pages are public and need no token — that is what makes half the checks possible.</a:t>
+              <a:t>The login pages are public and need no token - that is what makes half the checks possible.</a:t>
             </a:r>
           </a:p>
           <a:p>
@@ -21441,7 +21441,7 @@
                 </a:solidFill>
                 <a:latin typeface="Calibri"/>
               </a:rPr>
-              <a:t>•  Validate the target: confirm the URL is well-formed and safe to contact — the containment check (slide 9) — before any traffic is sent.</a:t>
+              <a:t>•  Validate the target: confirm the URL is well-formed and safe to contact - the containment check (slide 9) - before any traffic is sent.</a:t>
             </a:r>
           </a:p>
           <a:p>
@@ -21460,7 +21460,7 @@
                 </a:solidFill>
                 <a:latin typeface="Calibri"/>
               </a:rPr>
-              <a:t>•  Handshake: the opening MCP “initialize” exchange. The server may hand back a session id — a temporary “same conversation” label, not a password. We replay it so a server that merely wants one is not mistaken for secured.</a:t>
+              <a:t>•  Handshake: the opening MCP “initialize” exchange. The server may hand back a session id - a temporary “same conversation” label, not a password. We replay it so a server that merely wants one is not mistaken for secured.</a:t>
             </a:r>
           </a:p>
           <a:p>
@@ -21479,7 +21479,7 @@
                 </a:solidFill>
                 <a:latin typeface="Calibri"/>
               </a:rPr>
-              <a:t>•  Find the login pages: two public pages — where to log in, and the login server's own description. Two, because the MCP server and login server are often different companies. Fetched once and shared by every check that needs them.</a:t>
+              <a:t>•  Find the login pages: two public pages - where to log in, and the login server's own description. Two, because the MCP server and login server are often different companies. Fetched once and shared by every check that needs them.</a:t>
             </a:r>
           </a:p>
           <a:p>
@@ -21594,7 +21594,7 @@
                 </a:solidFill>
                 <a:latin typeface="Calibri"/>
               </a:rPr>
-              <a:t>Five possible answers — including an honest “I don't know”</a:t>
+              <a:t>Five possible answers - including an honest “I don't know”</a:t>
             </a:r>
           </a:p>
         </p:txBody>
@@ -22274,7 +22274,7 @@
                 </a:solidFill>
                 <a:latin typeface="Calibri"/>
               </a:rPr>
-              <a:t>INCONCLUSIVE is a real result — not a failure.</a:t>
+              <a:t>INCONCLUSIVE is a real result - not a failure.</a:t>
             </a:r>
           </a:p>
           <a:p>
@@ -22309,7 +22309,7 @@
                 </a:solidFill>
                 <a:latin typeface="Calibri"/>
               </a:rPr>
-              <a:t>Example — check #14 asks the login server to send the user back to an </a:t>
+              <a:t>Example - check #14 asks the login server to send the user back to an </a:t>
             </a:r>
             <a:r>
               <a:rPr sz="1350" b="0" i="1">
@@ -22327,7 +22327,7 @@
                 </a:solidFill>
                 <a:latin typeface="Calibri"/>
               </a:rPr>
-              <a:t> address. A correct server refuses; a broken one obeys. But many just answer 200 with a login page — and since we never log in, we can't see which way it resolves. Not a pass, not a gap: INCONCLUSIVE.</a:t>
+              <a:t> address. A correct server refuses; a broken one obeys. But many just answer 200 with a login page - and since we never log in, we can't see which way it resolves. Not a pass, not a gap: INCONCLUSIVE.</a:t>
             </a:r>
           </a:p>
         </p:txBody>
@@ -22465,7 +22465,7 @@
                 </a:solidFill>
                 <a:latin typeface="Calibri"/>
               </a:rPr>
-              <a:t>Each finding records the exact request we sent and the reply we got — the URL, the method, which headers we chose (an Authorization header is never present), and the response body.</a:t>
+              <a:t>Each finding records the exact request we sent and the reply we got - the URL, the method, which headers we chose (an Authorization header is never present), and the response body.</a:t>
             </a:r>
           </a:p>
           <a:p>
@@ -22722,7 +22722,7 @@
                 </a:solidFill>
                 <a:latin typeface="Calibri"/>
               </a:rPr>
-              <a:t>When a reply contains a secret — a token or client secret — we blank its value before writing to disk (client_secret: &lt;redacted&gt;), but keep the field name so the evidence still shows what the server returned.</a:t>
+              <a:t>When a reply contains a secret - a token or client secret - we blank its value before writing to disk (client_secret: &lt;redacted&gt;), but keep the field name so the evidence still shows what the server returned.</a:t>
             </a:r>
           </a:p>
         </p:txBody>
@@ -22857,7 +22857,7 @@
                 </a:solidFill>
                 <a:latin typeface="Calibri"/>
               </a:rPr>
-              <a:t>After the first request, almost every address the scanner visits is one the scanned server chose — where to log in, where to register. If we followed those blindly, a malicious server could aim our scanner at a victim of its choosing, and our tool would do the hitting for it.</a:t>
+              <a:t>After the first request, almost every address the scanner visits is one the scanned server chose - where to log in, where to register. If we followed those blindly, a malicious server could aim our scanner at a victim of its choosing, and our tool would do the hitting for it.</a:t>
             </a:r>
           </a:p>
         </p:txBody>
@@ -22918,7 +22918,7 @@
                 </a:solidFill>
                 <a:latin typeface="Calibri"/>
               </a:rPr>
-              <a:t>•  The only writes we make (registering a client) may reach the scanned server itself or a sibling on the same registered domain — never an unrelated third party.</a:t>
+              <a:t>•  The only writes we make (registering a client) may reach the scanned server itself or a sibling on the same registered domain - never an unrelated third party.</a:t>
             </a:r>
           </a:p>
         </p:txBody>
@@ -23005,7 +23005,7 @@
                 </a:solidFill>
                 <a:latin typeface="Calibri"/>
               </a:rPr>
-              <a:t>Real incident: while scanning api.serff.ai, an early version followed that server's own metadata to a registration endpoint on api.llow.io — a different company we never listed — and registered a client there. We added containment in response; it has since blocked one such cross-domain write (to login.semgrep.dev).</a:t>
+              <a:t>Real incident: while scanning api.serff.ai, an early version followed that server's own metadata to a registration endpoint on api.llow.io - a different company we never listed - and registered a client there. We added containment in response; it has since blocked one such cross-domain write (to login.semgrep.dev).</a:t>
             </a:r>
           </a:p>
         </p:txBody>

</xml_diff>